<commit_message>
Forecast deck test: autofit fix, overflow check, donut arcs, title zone
A ten-slide financial forecast (KPI tiles, stacked bars, waterfall, lines
over a band, heatmap, donut, table, bullets, gradient callout) surfaced three
more traps. Filled boxes collapsed to their text height because every shape
is exported with autofit on: meta.mjs now switches it off. Text that spills
its box in the browser wraps in PowerPoint: overflow.mjs finds it in headless
Chrome. Donuts from stroke-dasharray lost a segment: use path arcs.

Co-Authored-By: Claude Fable 5.1 <noreply@anthropic.com>
Claude-Session: https://claude.ai/code/session_016tX2Xyg9R5Kr2XEDEUZMer
</commit_message>
<xml_diff>
--- a/examples/charts.pptx
+++ b/examples/charts.pptx
@@ -1085,7 +1085,7 @@
         </p:spPr>
         <p:txBody>
           <a:bodyPr wrap="square" lIns="0" tIns="0" rIns="0" bIns="0" rtlCol="0" anchor="t">
-            <a:spAutoFit/>
+            <a:noAutofit/>
           </a:bodyPr>
           <a:lstStyle/>
           <a:p>
@@ -1206,7 +1206,7 @@
         </p:spPr>
         <p:txBody>
           <a:bodyPr wrap="square" lIns="0" tIns="0" rIns="0" bIns="0" rtlCol="0" anchor="t">
-            <a:spAutoFit/>
+            <a:noAutofit/>
           </a:bodyPr>
           <a:lstStyle/>
           <a:p>
@@ -1247,7 +1247,7 @@
         </p:spPr>
         <p:txBody>
           <a:bodyPr wrap="square" lIns="0" tIns="0" rIns="0" bIns="0" rtlCol="0" anchor="t">
-            <a:spAutoFit/>
+            <a:noAutofit/>
           </a:bodyPr>
           <a:lstStyle/>
           <a:p>
@@ -1288,7 +1288,7 @@
         </p:spPr>
         <p:txBody>
           <a:bodyPr wrap="square" lIns="0" tIns="0" rIns="0" bIns="0" rtlCol="0" anchor="t">
-            <a:spAutoFit/>
+            <a:noAutofit/>
           </a:bodyPr>
           <a:lstStyle/>
           <a:p>
@@ -1393,7 +1393,7 @@
         </p:spPr>
         <p:txBody>
           <a:bodyPr wrap="square" lIns="0" tIns="0" rIns="0" bIns="0" rtlCol="0" anchor="t">
-            <a:spAutoFit/>
+            <a:noAutofit/>
           </a:bodyPr>
           <a:lstStyle/>
           <a:p>
@@ -1478,7 +1478,7 @@
         </p:spPr>
         <p:txBody>
           <a:bodyPr wrap="square" lIns="0" tIns="0" rIns="0" bIns="0" rtlCol="0" anchor="t">
-            <a:spAutoFit/>
+            <a:noAutofit/>
           </a:bodyPr>
           <a:lstStyle/>
           <a:p>
@@ -1563,7 +1563,7 @@
         </p:spPr>
         <p:txBody>
           <a:bodyPr wrap="square" lIns="0" tIns="0" rIns="0" bIns="0" rtlCol="0" anchor="t">
-            <a:spAutoFit/>
+            <a:noAutofit/>
           </a:bodyPr>
           <a:lstStyle/>
           <a:p>
@@ -1648,7 +1648,7 @@
         </p:spPr>
         <p:txBody>
           <a:bodyPr wrap="square" lIns="0" tIns="0" rIns="0" bIns="0" rtlCol="0" anchor="t">
-            <a:spAutoFit/>
+            <a:noAutofit/>
           </a:bodyPr>
           <a:lstStyle/>
           <a:p>
@@ -1733,7 +1733,7 @@
         </p:spPr>
         <p:txBody>
           <a:bodyPr wrap="square" lIns="0" tIns="0" rIns="0" bIns="0" rtlCol="0" anchor="t">
-            <a:spAutoFit/>
+            <a:noAutofit/>
           </a:bodyPr>
           <a:lstStyle/>
           <a:p>
@@ -1774,7 +1774,7 @@
         </p:spPr>
         <p:txBody>
           <a:bodyPr wrap="square" lIns="0" tIns="0" rIns="0" bIns="0" rtlCol="0" anchor="t">
-            <a:spAutoFit/>
+            <a:noAutofit/>
           </a:bodyPr>
           <a:lstStyle/>
           <a:p>
@@ -1815,7 +1815,7 @@
         </p:spPr>
         <p:txBody>
           <a:bodyPr wrap="square" lIns="0" tIns="0" rIns="0" bIns="0" rtlCol="0" anchor="t">
-            <a:spAutoFit/>
+            <a:noAutofit/>
           </a:bodyPr>
           <a:lstStyle/>
           <a:p>
@@ -1876,7 +1876,7 @@
         </p:spPr>
         <p:txBody>
           <a:bodyPr wrap="square" lIns="0" tIns="0" rIns="0" bIns="0" rtlCol="0" anchor="t">
-            <a:spAutoFit/>
+            <a:noAutofit/>
           </a:bodyPr>
           <a:lstStyle/>
           <a:p>
@@ -1937,7 +1937,7 @@
         </p:spPr>
         <p:txBody>
           <a:bodyPr wrap="square" lIns="0" tIns="0" rIns="0" bIns="0" rtlCol="0" anchor="t">
-            <a:spAutoFit/>
+            <a:noAutofit/>
           </a:bodyPr>
           <a:lstStyle/>
           <a:p>
@@ -2023,7 +2023,7 @@
         </p:spPr>
         <p:txBody>
           <a:bodyPr wrap="square" lIns="0" tIns="0" rIns="0" bIns="0" rtlCol="0" anchor="t">
-            <a:spAutoFit/>
+            <a:noAutofit/>
           </a:bodyPr>
           <a:lstStyle/>
           <a:p>
@@ -2139,7 +2139,7 @@
         </p:spPr>
         <p:txBody>
           <a:bodyPr wrap="square" lIns="0" tIns="0" rIns="0" bIns="0" rtlCol="0" anchor="t">
-            <a:spAutoFit/>
+            <a:noAutofit/>
           </a:bodyPr>
           <a:lstStyle/>
           <a:p>
@@ -2412,7 +2412,7 @@
         </p:spPr>
         <p:txBody>
           <a:bodyPr wrap="square" lIns="0" tIns="0" rIns="0" bIns="0" rtlCol="0" anchor="t">
-            <a:spAutoFit/>
+            <a:noAutofit/>
           </a:bodyPr>
           <a:lstStyle/>
           <a:p>
@@ -2453,7 +2453,7 @@
         </p:spPr>
         <p:txBody>
           <a:bodyPr wrap="square" lIns="0" tIns="0" rIns="0" bIns="0" rtlCol="0" anchor="t">
-            <a:spAutoFit/>
+            <a:noAutofit/>
           </a:bodyPr>
           <a:lstStyle/>
           <a:p>
@@ -2494,7 +2494,7 @@
         </p:spPr>
         <p:txBody>
           <a:bodyPr wrap="square" lIns="0" tIns="0" rIns="0" bIns="0" rtlCol="0" anchor="t">
-            <a:spAutoFit/>
+            <a:noAutofit/>
           </a:bodyPr>
           <a:lstStyle/>
           <a:p>
@@ -2535,7 +2535,7 @@
         </p:spPr>
         <p:txBody>
           <a:bodyPr wrap="square" lIns="0" tIns="0" rIns="0" bIns="0" rtlCol="0" anchor="t">
-            <a:spAutoFit/>
+            <a:noAutofit/>
           </a:bodyPr>
           <a:lstStyle/>
           <a:p>
@@ -2576,7 +2576,7 @@
         </p:spPr>
         <p:txBody>
           <a:bodyPr wrap="square" lIns="0" tIns="0" rIns="0" bIns="0" rtlCol="0" anchor="t">
-            <a:spAutoFit/>
+            <a:noAutofit/>
           </a:bodyPr>
           <a:lstStyle/>
           <a:p>
@@ -2617,7 +2617,7 @@
         </p:spPr>
         <p:txBody>
           <a:bodyPr wrap="square" lIns="0" tIns="0" rIns="0" bIns="0" rtlCol="0" anchor="t">
-            <a:spAutoFit/>
+            <a:noAutofit/>
           </a:bodyPr>
           <a:lstStyle/>
           <a:p>
@@ -2704,7 +2704,7 @@
         </p:spPr>
         <p:txBody>
           <a:bodyPr wrap="square" lIns="114300" tIns="95250" rIns="114300" bIns="95250" rtlCol="0" anchor="t">
-            <a:spAutoFit/>
+            <a:noAutofit/>
           </a:bodyPr>
           <a:lstStyle/>
           <a:p>

</xml_diff>